<commit_message>
docs: remove Codex mention from presentation
</commit_message>
<xml_diff>
--- a/presentation/Jana_Address_Pitch_Terricon_2026_team73.pptx
+++ b/presentation/Jana_Address_Pitch_Terricon_2026_team73.pptx
@@ -2,15 +2,15 @@
 <file path=ppt/presentation.xml><?xml version="1.0" encoding="utf-8"?>
 <p:presentation xmlns:p="http://schemas.openxmlformats.org/presentationml/2006/main">
   <p:sldMasterIdLst>
-    <p:sldMasterId xmlns:r="http://schemas.openxmlformats.org/officeDocument/2006/relationships" id="2147483648" r:id="R378a6999aa524199"/>
+    <p:sldMasterId xmlns:r="http://schemas.openxmlformats.org/officeDocument/2006/relationships" id="2147483648" r:id="R06c7fc2132fe4f71"/>
   </p:sldMasterIdLst>
   <p:notesMasterIdLst>
-    <p:notesMasterId xmlns:r="http://schemas.openxmlformats.org/officeDocument/2006/relationships" r:id="R2d3506abe86a41ef"/>
+    <p:notesMasterId xmlns:r="http://schemas.openxmlformats.org/officeDocument/2006/relationships" r:id="Rb1d409be59b44ebb"/>
   </p:notesMasterIdLst>
   <p:sldIdLst>
-    <p:sldId xmlns:r="http://schemas.openxmlformats.org/officeDocument/2006/relationships" id="256" r:id="R1f76d8bc27b94c5c"/>
-    <p:sldId xmlns:r="http://schemas.openxmlformats.org/officeDocument/2006/relationships" id="257" r:id="Rb32585ccacb443bb"/>
-    <p:sldId xmlns:r="http://schemas.openxmlformats.org/officeDocument/2006/relationships" id="258" r:id="Rad2b4f0e72794d4f"/>
+    <p:sldId xmlns:r="http://schemas.openxmlformats.org/officeDocument/2006/relationships" id="256" r:id="Rdf5a4b14492644e7"/>
+    <p:sldId xmlns:r="http://schemas.openxmlformats.org/officeDocument/2006/relationships" id="257" r:id="R5d9efd53a1d441a9"/>
+    <p:sldId xmlns:r="http://schemas.openxmlformats.org/officeDocument/2006/relationships" id="258" r:id="R79f1b10eb99b48a4"/>
   </p:sldIdLst>
   <p:sldSz cx="12192000" cy="6858000"/>
   <p:notesSz cx="6858000" cy="9144000"/>
@@ -3027,12 +3027,12 @@
   </p:cSld>
   <p:clrMap bg1="lt1" tx1="dk1" bg2="lt2" tx2="dk2" accent1="accent1" accent2="accent2" accent3="accent3" accent4="accent4" accent5="accent5" accent6="accent6" hlink="hlink" folHlink="folHlink"/>
   <p:sldLayoutIdLst>
-    <p:sldLayoutId xmlns:r="http://schemas.openxmlformats.org/officeDocument/2006/relationships" id="2147483649" r:id="Ree6b47b207cd4a7c"/>
-    <p:sldLayoutId xmlns:r="http://schemas.openxmlformats.org/officeDocument/2006/relationships" id="2147483650" r:id="R3bf3abccca6249ad"/>
-    <p:sldLayoutId xmlns:r="http://schemas.openxmlformats.org/officeDocument/2006/relationships" id="2147483651" r:id="Ra816920558db4d4d"/>
-    <p:sldLayoutId xmlns:r="http://schemas.openxmlformats.org/officeDocument/2006/relationships" id="2147483652" r:id="R23333fecc4514e17"/>
-    <p:sldLayoutId xmlns:r="http://schemas.openxmlformats.org/officeDocument/2006/relationships" id="2147483653" r:id="R6867985fc4b4443e"/>
-    <p:sldLayoutId xmlns:r="http://schemas.openxmlformats.org/officeDocument/2006/relationships" id="2147483654" r:id="Ra91fa71784f54485"/>
+    <p:sldLayoutId xmlns:r="http://schemas.openxmlformats.org/officeDocument/2006/relationships" id="2147483649" r:id="R4f44d32548b048c1"/>
+    <p:sldLayoutId xmlns:r="http://schemas.openxmlformats.org/officeDocument/2006/relationships" id="2147483650" r:id="R35be48127e444c07"/>
+    <p:sldLayoutId xmlns:r="http://schemas.openxmlformats.org/officeDocument/2006/relationships" id="2147483651" r:id="R983bf32a61fb463f"/>
+    <p:sldLayoutId xmlns:r="http://schemas.openxmlformats.org/officeDocument/2006/relationships" id="2147483652" r:id="R6c62c636c9a74a9d"/>
+    <p:sldLayoutId xmlns:r="http://schemas.openxmlformats.org/officeDocument/2006/relationships" id="2147483653" r:id="Re55d6835f6d443b5"/>
+    <p:sldLayoutId xmlns:r="http://schemas.openxmlformats.org/officeDocument/2006/relationships" id="2147483654" r:id="R862f0f89fff04a85"/>
   </p:sldLayoutIdLst>
   <p:txStyles>
     <p:titleStyle>
@@ -3614,7 +3614,7 @@
           <p:cNvPr id="2" name="">
             <a:extLst xmlns:a="http://schemas.openxmlformats.org/drawingml/2006/main">
               <a:ext uri="{FF2B5EF4-FFF2-40B4-BE49-F238E27FC236}">
-                <a16:creationId xmlns:a16="http://schemas.microsoft.com/office/drawing/2014/main" id="{83C7268D-6651-4195-B4AF-B53BA22671B2}"/>
+                <a16:creationId xmlns:a16="http://schemas.microsoft.com/office/drawing/2014/main" id="{B16BEB45-2673-4553-BBF6-E7BBC0F04A65}"/>
               </a:ext>
             </a:extLst>
           </p:cNvPr>
@@ -3624,7 +3624,7 @@
           <p:nvPr/>
         </p:nvPicPr>
         <p:blipFill>
-          <a:blip xmlns:r="http://schemas.openxmlformats.org/officeDocument/2006/relationships" xmlns:a="http://schemas.openxmlformats.org/drawingml/2006/main" r:embed="R40bf403efa894055"/>
+          <a:blip xmlns:r="http://schemas.openxmlformats.org/officeDocument/2006/relationships" xmlns:a="http://schemas.openxmlformats.org/drawingml/2006/main" r:embed="Re4a24078cf314513"/>
           <a:srcRect xmlns:a="http://schemas.openxmlformats.org/drawingml/2006/main" l="44000" t="0" r="0" b="0"/>
           <a:stretch xmlns:a="http://schemas.openxmlformats.org/drawingml/2006/main"/>
         </p:blipFill>
@@ -4792,7 +4792,7 @@
           <p:cNvPr id="2" name="">
             <a:extLst xmlns:a="http://schemas.openxmlformats.org/drawingml/2006/main">
               <a:ext uri="{FF2B5EF4-FFF2-40B4-BE49-F238E27FC236}">
-                <a16:creationId xmlns:a16="http://schemas.microsoft.com/office/drawing/2014/main" id="{78C50F71-1432-49F8-A861-8E5237CEE2E7}"/>
+                <a16:creationId xmlns:a16="http://schemas.microsoft.com/office/drawing/2014/main" id="{6340634E-9847-44E0-B865-B9B606BF944F}"/>
               </a:ext>
             </a:extLst>
           </p:cNvPr>
@@ -4802,7 +4802,7 @@
           <p:nvPr/>
         </p:nvPicPr>
         <p:blipFill>
-          <a:blip xmlns:r="http://schemas.openxmlformats.org/officeDocument/2006/relationships" xmlns:a="http://schemas.openxmlformats.org/drawingml/2006/main" r:embed="Rd8ac699685a8413f"/>
+          <a:blip xmlns:r="http://schemas.openxmlformats.org/officeDocument/2006/relationships" xmlns:a="http://schemas.openxmlformats.org/drawingml/2006/main" r:embed="Rc78ca501409442c1"/>
           <a:srcRect xmlns:a="http://schemas.openxmlformats.org/drawingml/2006/main" l="44000" t="0" r="0" b="0"/>
           <a:stretch xmlns:a="http://schemas.openxmlformats.org/drawingml/2006/main"/>
         </p:blipFill>
@@ -5797,33 +5797,6 @@
                 <a:cs typeface="Arial"/>
               </a:rPr>
               <a:t>pytest и Node test runner</a:t>
-            </a:r>
-          </a:p>
-          <a:p xmlns:a="http://schemas.openxmlformats.org/drawingml/2006/main">
-            <a:pPr>
-              <a:lnSpc>
-                <a:spcPct val="112000"/>
-              </a:lnSpc>
-              <a:buNone/>
-              <a:defRPr sz="1500">
-                <a:solidFill>
-                  <a:srgbClr val="242824"/>
-                </a:solidFill>
-                <a:latin typeface="Arial"/>
-                <a:ea typeface="Arial"/>
-                <a:cs typeface="Arial"/>
-              </a:defRPr>
-            </a:pPr>
-            <a:r>
-              <a:rPr sz="1500">
-                <a:solidFill>
-                  <a:srgbClr val="242824"/>
-                </a:solidFill>
-                <a:latin typeface="Arial"/>
-                <a:ea typeface="Arial"/>
-                <a:cs typeface="Arial"/>
-              </a:rPr>
-              <a:t>OpenAI Codex для разработки, проверки и документации</a:t>
             </a:r>
           </a:p>
           <a:p xmlns:a="http://schemas.openxmlformats.org/drawingml/2006/main">
@@ -7526,7 +7499,7 @@
           <p:cNvPr id="3" name="">
             <a:extLst xmlns:a="http://schemas.openxmlformats.org/drawingml/2006/main">
               <a:ext uri="{FF2B5EF4-FFF2-40B4-BE49-F238E27FC236}">
-                <a16:creationId xmlns:a16="http://schemas.microsoft.com/office/drawing/2014/main" id="{0E2A0168-271E-4FA6-9419-1F1479BEC0D5}"/>
+                <a16:creationId xmlns:a16="http://schemas.microsoft.com/office/drawing/2014/main" id="{01DA99F1-70C4-4491-A209-10A907BE3755}"/>
               </a:ext>
             </a:extLst>
           </p:cNvPr>
@@ -7536,7 +7509,7 @@
           <p:nvPr/>
         </p:nvPicPr>
         <p:blipFill>
-          <a:blip xmlns:r="http://schemas.openxmlformats.org/officeDocument/2006/relationships" xmlns:a="http://schemas.openxmlformats.org/drawingml/2006/main" r:embed="R598d456b0481435b"/>
+          <a:blip xmlns:r="http://schemas.openxmlformats.org/officeDocument/2006/relationships" xmlns:a="http://schemas.openxmlformats.org/drawingml/2006/main" r:embed="R1ca49d0ec6ba45ad"/>
           <a:srcRect xmlns:a="http://schemas.openxmlformats.org/drawingml/2006/main" l="0" t="1000" r="0" b="3000"/>
           <a:stretch xmlns:a="http://schemas.openxmlformats.org/drawingml/2006/main"/>
         </p:blipFill>
@@ -7557,7 +7530,7 @@
           <p:cNvPr id="4" name="">
             <a:extLst xmlns:a="http://schemas.openxmlformats.org/drawingml/2006/main">
               <a:ext uri="{FF2B5EF4-FFF2-40B4-BE49-F238E27FC236}">
-                <a16:creationId xmlns:a16="http://schemas.microsoft.com/office/drawing/2014/main" id="{FF47694F-8A0C-46D4-9088-4F69AE1CAD70}"/>
+                <a16:creationId xmlns:a16="http://schemas.microsoft.com/office/drawing/2014/main" id="{EAA12B7D-B01C-4542-8021-26F44D561F0B}"/>
               </a:ext>
             </a:extLst>
           </p:cNvPr>
@@ -7567,7 +7540,7 @@
           <p:nvPr/>
         </p:nvPicPr>
         <p:blipFill>
-          <a:blip xmlns:r="http://schemas.openxmlformats.org/officeDocument/2006/relationships" xmlns:a="http://schemas.openxmlformats.org/drawingml/2006/main" r:embed="R30ef6e887e604fc7"/>
+          <a:blip xmlns:r="http://schemas.openxmlformats.org/officeDocument/2006/relationships" xmlns:a="http://schemas.openxmlformats.org/drawingml/2006/main" r:embed="R68645a5bdf2b4417"/>
           <a:srcRect xmlns:a="http://schemas.openxmlformats.org/drawingml/2006/main" l="0" t="1000" r="0" b="3000"/>
           <a:stretch xmlns:a="http://schemas.openxmlformats.org/drawingml/2006/main"/>
         </p:blipFill>

</xml_diff>

<commit_message>
Generalize address lookup across Kazakhstan
</commit_message>
<xml_diff>
--- a/presentation/Jana_Address_Pitch_Terricon_2026_team73.pptx
+++ b/presentation/Jana_Address_Pitch_Terricon_2026_team73.pptx
@@ -160,9 +160,9 @@
 </file>
 
 <file path=ppt/notesMasters/theme/theme3.xml><?xml version="1.0" encoding="utf-8"?>
-<a:theme xmlns:a="http://schemas.openxmlformats.org/drawingml/2006/main" name="ChatGPT">
+<a:theme xmlns:a="http://schemas.openxmlformats.org/drawingml/2006/main" name="Jana Address">
   <a:themeElements>
-    <a:clrScheme name="ChatGPT">
+    <a:clrScheme name="Jana Address">
       <a:dk1>
         <a:srgbClr val="000000"/>
       </a:dk1>
@@ -212,7 +212,7 @@
         <a:cs typeface=""/>
       </a:minorFont>
     </a:fontScheme>
-    <a:fmtScheme name="ChatGPT">
+    <a:fmtScheme name="Jana Address">
       <a:fillStyleLst>
         <a:solidFill>
           <a:schemeClr val="phClr"/>
@@ -3315,9 +3315,9 @@
 </file>
 
 <file path=ppt/slideMasters/theme/theme2.xml><?xml version="1.0" encoding="utf-8"?>
-<a:theme xmlns:a="http://schemas.openxmlformats.org/drawingml/2006/main" name="ChatGPT">
+<a:theme xmlns:a="http://schemas.openxmlformats.org/drawingml/2006/main" name="Jana Address">
   <a:themeElements>
-    <a:clrScheme name="ChatGPT">
+    <a:clrScheme name="Jana Address">
       <a:dk1>
         <a:srgbClr val="000000"/>
       </a:dk1>
@@ -3367,7 +3367,7 @@
         <a:cs typeface=""/>
       </a:minorFont>
     </a:fontScheme>
-    <a:fmtScheme name="ChatGPT">
+    <a:fmtScheme name="Jana Address">
       <a:fillStyleLst>
         <a:solidFill>
           <a:schemeClr val="phClr"/>
@@ -8236,9 +8236,9 @@
 </file>
 
 <file path=ppt/theme/theme1.xml><?xml version="1.0" encoding="utf-8"?>
-<a:theme xmlns:a="http://schemas.openxmlformats.org/drawingml/2006/main" name="ChatGPT">
+<a:theme xmlns:a="http://schemas.openxmlformats.org/drawingml/2006/main" name="Jana Address">
   <a:themeElements>
-    <a:clrScheme name="ChatGPT">
+    <a:clrScheme name="Jana Address">
       <a:dk1>
         <a:srgbClr val="000000"/>
       </a:dk1>
@@ -8288,7 +8288,7 @@
         <a:cs typeface=""/>
       </a:minorFont>
     </a:fontScheme>
-    <a:fmtScheme name="ChatGPT">
+    <a:fmtScheme name="Jana Address">
       <a:fillStyleLst>
         <a:solidFill>
           <a:schemeClr val="phClr"/>

</xml_diff>